<commit_message>
CEA055 Aulas 1, 2, 3, 6 e 8: slides corrigidos na auditoria de 22/10
- Aulas 1, 2, 3 e 8: slide de atividades dividido; exercícios iguais à tabela de referências
- Aulas 3 e 6: PDF e deck com o cabeçalho atual
- Aula 6: Teorema de Bayes sem encostar no rodapé
- Aula 1: deck do site atualizado para a versão do Drive

Co-Authored-By: Claude Opus 5.5 <noreply@anthropic.com>
</commit_message>
<xml_diff>
--- a/content/2026-2/cea055-estatistica-probabilidade/01-estatistica-descritiva-i/Aula_01_Estatistica_Descritiva_I.pptx
+++ b/content/2026-2/cea055-estatistica-probabilidade/01-estatistica-descritiva-i/Aula_01_Estatistica_Descritiva_I.pptx
@@ -5,7 +5,7 @@
     <p:sldMasterId id="2147483648" r:id="rId1"/>
   </p:sldMasterIdLst>
   <p:notesMasterIdLst>
-    <p:notesMasterId r:id="rId36"/>
+    <p:notesMasterId r:id="rId37"/>
   </p:notesMasterIdLst>
   <p:sldIdLst>
     <p:sldId id="311" r:id="rId2"/>
@@ -42,6 +42,7 @@
     <p:sldId id="340" r:id="rId33"/>
     <p:sldId id="341" r:id="rId34"/>
     <p:sldId id="342" r:id="rId35"/>
+    <p:sldId id="355" r:id="rId36"/>
   </p:sldIdLst>
   <p:sldSz cx="12192000" cy="6858000"/>
   <p:notesSz cx="6858000" cy="9144000"/>
@@ -993,26 +994,6 @@
         </a:ln>
         <a:effectLst/>
       </c:spPr>
-      <c:txPr>
-        <a:bodyPr rot="0" spcFirstLastPara="1" vertOverflow="ellipsis" vert="horz" wrap="square" anchor="ctr" anchorCtr="1"/>
-        <a:lstStyle/>
-        <a:p>
-          <a:pPr>
-            <a:defRPr sz="2160" b="0" i="0" u="none" strike="noStrike" kern="1200" spc="0" baseline="0">
-              <a:solidFill>
-                <a:schemeClr val="tx1">
-                  <a:lumMod val="65000"/>
-                  <a:lumOff val="35000"/>
-                </a:schemeClr>
-              </a:solidFill>
-              <a:latin typeface="+mn-lt"/>
-              <a:ea typeface="+mn-ea"/>
-              <a:cs typeface="+mn-cs"/>
-            </a:defRPr>
-          </a:pPr>
-          <a:endParaRPr lang="pt-BR"/>
-        </a:p>
-      </c:txPr>
     </c:title>
     <c:autoTitleDeleted val="0"/>
     <c:plotArea>
@@ -1063,26 +1044,6 @@
                 </a:ln>
                 <a:effectLst/>
               </c:spPr>
-              <c:txPr>
-                <a:bodyPr rot="0" spcFirstLastPara="1" vertOverflow="ellipsis" vert="horz" wrap="square" anchor="ctr" anchorCtr="1"/>
-                <a:lstStyle/>
-                <a:p>
-                  <a:pPr>
-                    <a:defRPr sz="1800" b="0" i="0" u="none" strike="noStrike" kern="1200" baseline="0">
-                      <a:solidFill>
-                        <a:schemeClr val="tx1">
-                          <a:lumMod val="75000"/>
-                          <a:lumOff val="25000"/>
-                        </a:schemeClr>
-                      </a:solidFill>
-                      <a:latin typeface="+mn-lt"/>
-                      <a:ea typeface="+mn-ea"/>
-                      <a:cs typeface="+mn-cs"/>
-                    </a:defRPr>
-                  </a:pPr>
-                  <a:endParaRPr lang="pt-BR"/>
-                </a:p>
-              </c:txPr>
               <c:showLegendKey val="0"/>
               <c:showVal val="1"/>
               <c:showCatName val="0"/>
@@ -1091,18 +1052,6 @@
               <c:showBubbleSize val="0"/>
               <c:extLst>
                 <c:ext xmlns:c15="http://schemas.microsoft.com/office/drawing/2012/chart" uri="{CE6537A1-D6FC-4f65-9D91-7224C49458BB}">
-                  <c15:dlblFieldTable>
-                    <c15:dlblFTEntry>
-                      <c15:txfldGUID>{9BB0E77C-C640-4960-A8DD-290019CB0C55}</c15:txfldGUID>
-                      <c15:f>Planilha1!$L$3</c15:f>
-                      <c15:dlblFieldTableCache>
-                        <c:ptCount val="1"/>
-                        <c:pt idx="0">
-                          <c:v>27,78</c:v>
-                        </c:pt>
-                      </c15:dlblFieldTableCache>
-                    </c15:dlblFTEntry>
-                  </c15:dlblFieldTable>
                   <c15:showDataLabelsRange val="0"/>
                 </c:ext>
                 <c:ext xmlns:c16="http://schemas.microsoft.com/office/drawing/2014/chart" uri="{C3380CC4-5D6E-409C-BE32-E72D297353CC}">
@@ -1138,26 +1087,6 @@
                 </a:ln>
                 <a:effectLst/>
               </c:spPr>
-              <c:txPr>
-                <a:bodyPr rot="0" spcFirstLastPara="1" vertOverflow="ellipsis" vert="horz" wrap="square" anchor="ctr" anchorCtr="1"/>
-                <a:lstStyle/>
-                <a:p>
-                  <a:pPr>
-                    <a:defRPr sz="1800" b="0" i="0" u="none" strike="noStrike" kern="1200" baseline="0">
-                      <a:solidFill>
-                        <a:schemeClr val="tx1">
-                          <a:lumMod val="75000"/>
-                          <a:lumOff val="25000"/>
-                        </a:schemeClr>
-                      </a:solidFill>
-                      <a:latin typeface="+mn-lt"/>
-                      <a:ea typeface="+mn-ea"/>
-                      <a:cs typeface="+mn-cs"/>
-                    </a:defRPr>
-                  </a:pPr>
-                  <a:endParaRPr lang="pt-BR"/>
-                </a:p>
-              </c:txPr>
               <c:showLegendKey val="0"/>
               <c:showVal val="1"/>
               <c:showCatName val="0"/>
@@ -1166,18 +1095,6 @@
               <c:showBubbleSize val="0"/>
               <c:extLst>
                 <c:ext xmlns:c15="http://schemas.microsoft.com/office/drawing/2012/chart" uri="{CE6537A1-D6FC-4f65-9D91-7224C49458BB}">
-                  <c15:dlblFieldTable>
-                    <c15:dlblFTEntry>
-                      <c15:txfldGUID>{A5B2F4DC-0742-48D4-B4CA-2172A0F59765}</c15:txfldGUID>
-                      <c15:f>Planilha1!$L$4</c15:f>
-                      <c15:dlblFieldTableCache>
-                        <c:ptCount val="1"/>
-                        <c:pt idx="0">
-                          <c:v>33,33</c:v>
-                        </c:pt>
-                      </c15:dlblFieldTableCache>
-                    </c15:dlblFTEntry>
-                  </c15:dlblFieldTable>
                   <c15:showDataLabelsRange val="0"/>
                 </c:ext>
                 <c:ext xmlns:c16="http://schemas.microsoft.com/office/drawing/2014/chart" uri="{C3380CC4-5D6E-409C-BE32-E72D297353CC}">
@@ -1213,26 +1130,6 @@
                 </a:ln>
                 <a:effectLst/>
               </c:spPr>
-              <c:txPr>
-                <a:bodyPr rot="0" spcFirstLastPara="1" vertOverflow="ellipsis" vert="horz" wrap="square" anchor="ctr" anchorCtr="1"/>
-                <a:lstStyle/>
-                <a:p>
-                  <a:pPr>
-                    <a:defRPr sz="1800" b="0" i="0" u="none" strike="noStrike" kern="1200" baseline="0">
-                      <a:solidFill>
-                        <a:schemeClr val="tx1">
-                          <a:lumMod val="75000"/>
-                          <a:lumOff val="25000"/>
-                        </a:schemeClr>
-                      </a:solidFill>
-                      <a:latin typeface="+mn-lt"/>
-                      <a:ea typeface="+mn-ea"/>
-                      <a:cs typeface="+mn-cs"/>
-                    </a:defRPr>
-                  </a:pPr>
-                  <a:endParaRPr lang="pt-BR"/>
-                </a:p>
-              </c:txPr>
               <c:showLegendKey val="0"/>
               <c:showVal val="1"/>
               <c:showCatName val="0"/>
@@ -1241,18 +1138,6 @@
               <c:showBubbleSize val="0"/>
               <c:extLst>
                 <c:ext xmlns:c15="http://schemas.microsoft.com/office/drawing/2012/chart" uri="{CE6537A1-D6FC-4f65-9D91-7224C49458BB}">
-                  <c15:dlblFieldTable>
-                    <c15:dlblFTEntry>
-                      <c15:txfldGUID>{2E11B46C-42CA-4222-9D7F-C451977FBD47}</c15:txfldGUID>
-                      <c15:f>Planilha1!$L$5</c15:f>
-                      <c15:dlblFieldTableCache>
-                        <c:ptCount val="1"/>
-                        <c:pt idx="0">
-                          <c:v>22,22</c:v>
-                        </c:pt>
-                      </c15:dlblFieldTableCache>
-                    </c15:dlblFTEntry>
-                  </c15:dlblFieldTable>
                   <c15:showDataLabelsRange val="0"/>
                 </c:ext>
                 <c:ext xmlns:c16="http://schemas.microsoft.com/office/drawing/2014/chart" uri="{C3380CC4-5D6E-409C-BE32-E72D297353CC}">
@@ -1288,26 +1173,6 @@
                 </a:ln>
                 <a:effectLst/>
               </c:spPr>
-              <c:txPr>
-                <a:bodyPr rot="0" spcFirstLastPara="1" vertOverflow="ellipsis" vert="horz" wrap="square" anchor="ctr" anchorCtr="1"/>
-                <a:lstStyle/>
-                <a:p>
-                  <a:pPr>
-                    <a:defRPr sz="1800" b="0" i="0" u="none" strike="noStrike" kern="1200" baseline="0">
-                      <a:solidFill>
-                        <a:schemeClr val="tx1">
-                          <a:lumMod val="75000"/>
-                          <a:lumOff val="25000"/>
-                        </a:schemeClr>
-                      </a:solidFill>
-                      <a:latin typeface="+mn-lt"/>
-                      <a:ea typeface="+mn-ea"/>
-                      <a:cs typeface="+mn-cs"/>
-                    </a:defRPr>
-                  </a:pPr>
-                  <a:endParaRPr lang="pt-BR"/>
-                </a:p>
-              </c:txPr>
               <c:showLegendKey val="0"/>
               <c:showVal val="1"/>
               <c:showCatName val="0"/>
@@ -1316,18 +1181,6 @@
               <c:showBubbleSize val="0"/>
               <c:extLst>
                 <c:ext xmlns:c15="http://schemas.microsoft.com/office/drawing/2012/chart" uri="{CE6537A1-D6FC-4f65-9D91-7224C49458BB}">
-                  <c15:dlblFieldTable>
-                    <c15:dlblFTEntry>
-                      <c15:txfldGUID>{E30A4D3E-B67D-4D1F-B73E-9237DE80372D}</c15:txfldGUID>
-                      <c15:f>Planilha1!$L$6</c15:f>
-                      <c15:dlblFieldTableCache>
-                        <c:ptCount val="1"/>
-                        <c:pt idx="0">
-                          <c:v>13,89</c:v>
-                        </c:pt>
-                      </c15:dlblFieldTableCache>
-                    </c15:dlblFTEntry>
-                  </c15:dlblFieldTable>
                   <c15:showDataLabelsRange val="0"/>
                 </c:ext>
                 <c:ext xmlns:c16="http://schemas.microsoft.com/office/drawing/2014/chart" uri="{C3380CC4-5D6E-409C-BE32-E72D297353CC}">
@@ -1363,26 +1216,6 @@
                 </a:ln>
                 <a:effectLst/>
               </c:spPr>
-              <c:txPr>
-                <a:bodyPr rot="0" spcFirstLastPara="1" vertOverflow="ellipsis" vert="horz" wrap="square" anchor="ctr" anchorCtr="1"/>
-                <a:lstStyle/>
-                <a:p>
-                  <a:pPr>
-                    <a:defRPr sz="1800" b="0" i="0" u="none" strike="noStrike" kern="1200" baseline="0">
-                      <a:solidFill>
-                        <a:schemeClr val="tx1">
-                          <a:lumMod val="75000"/>
-                          <a:lumOff val="25000"/>
-                        </a:schemeClr>
-                      </a:solidFill>
-                      <a:latin typeface="+mn-lt"/>
-                      <a:ea typeface="+mn-ea"/>
-                      <a:cs typeface="+mn-cs"/>
-                    </a:defRPr>
-                  </a:pPr>
-                  <a:endParaRPr lang="pt-BR"/>
-                </a:p>
-              </c:txPr>
               <c:showLegendKey val="0"/>
               <c:showVal val="1"/>
               <c:showCatName val="0"/>
@@ -1391,18 +1224,6 @@
               <c:showBubbleSize val="0"/>
               <c:extLst>
                 <c:ext xmlns:c15="http://schemas.microsoft.com/office/drawing/2012/chart" uri="{CE6537A1-D6FC-4f65-9D91-7224C49458BB}">
-                  <c15:dlblFieldTable>
-                    <c15:dlblFTEntry>
-                      <c15:txfldGUID>{4C758184-E731-45DF-8733-2179A3402C36}</c15:txfldGUID>
-                      <c15:f>Planilha1!$L$7</c15:f>
-                      <c15:dlblFieldTableCache>
-                        <c:ptCount val="1"/>
-                        <c:pt idx="0">
-                          <c:v>2,78</c:v>
-                        </c:pt>
-                      </c15:dlblFieldTableCache>
-                    </c15:dlblFTEntry>
-                  </c15:dlblFieldTable>
                   <c15:showDataLabelsRange val="0"/>
                 </c:ext>
                 <c:ext xmlns:c16="http://schemas.microsoft.com/office/drawing/2014/chart" uri="{C3380CC4-5D6E-409C-BE32-E72D297353CC}">
@@ -1571,26 +1392,6 @@
             </a:ln>
             <a:effectLst/>
           </c:spPr>
-          <c:txPr>
-            <a:bodyPr rot="0" spcFirstLastPara="1" vertOverflow="ellipsis" vert="horz" wrap="square" anchor="ctr" anchorCtr="1"/>
-            <a:lstStyle/>
-            <a:p>
-              <a:pPr>
-                <a:defRPr sz="1800" b="0" i="0" u="none" strike="noStrike" kern="1200" baseline="0">
-                  <a:solidFill>
-                    <a:schemeClr val="tx1">
-                      <a:lumMod val="65000"/>
-                      <a:lumOff val="35000"/>
-                    </a:schemeClr>
-                  </a:solidFill>
-                  <a:latin typeface="+mn-lt"/>
-                  <a:ea typeface="+mn-ea"/>
-                  <a:cs typeface="+mn-cs"/>
-                </a:defRPr>
-              </a:pPr>
-              <a:endParaRPr lang="pt-BR"/>
-            </a:p>
-          </c:txPr>
         </c:title>
         <c:numFmt formatCode="General" sourceLinked="1"/>
         <c:majorTickMark val="none"/>
@@ -1692,26 +1493,6 @@
             </a:ln>
             <a:effectLst/>
           </c:spPr>
-          <c:txPr>
-            <a:bodyPr rot="-5400000" spcFirstLastPara="1" vertOverflow="ellipsis" vert="horz" wrap="square" anchor="ctr" anchorCtr="1"/>
-            <a:lstStyle/>
-            <a:p>
-              <a:pPr>
-                <a:defRPr sz="1800" b="0" i="0" u="none" strike="noStrike" kern="1200" baseline="0">
-                  <a:solidFill>
-                    <a:schemeClr val="tx1">
-                      <a:lumMod val="65000"/>
-                      <a:lumOff val="35000"/>
-                    </a:schemeClr>
-                  </a:solidFill>
-                  <a:latin typeface="+mn-lt"/>
-                  <a:ea typeface="+mn-ea"/>
-                  <a:cs typeface="+mn-cs"/>
-                </a:defRPr>
-              </a:pPr>
-              <a:endParaRPr lang="pt-BR"/>
-            </a:p>
-          </c:txPr>
         </c:title>
         <c:numFmt formatCode="General" sourceLinked="1"/>
         <c:majorTickMark val="none"/>
@@ -1792,7 +1573,7 @@
       <a:endParaRPr lang="pt-BR"/>
     </a:p>
   </c:txPr>
-  <c:externalData r:id="rId4">
+  <c:externalData r:id="rId2">
     <c:autoUpdate val="0"/>
   </c:externalData>
 </c:chartSpace>
@@ -2243,46 +2024,6 @@
 </file>
 
 <file path=ppt/charts/colors2.xml><?xml version="1.0" encoding="utf-8"?>
-<cs:colorStyle xmlns:cs="http://schemas.microsoft.com/office/drawing/2012/chartStyle" xmlns:a="http://schemas.openxmlformats.org/drawingml/2006/main" meth="cycle" id="10">
-  <a:schemeClr val="accent1"/>
-  <a:schemeClr val="accent2"/>
-  <a:schemeClr val="accent3"/>
-  <a:schemeClr val="accent4"/>
-  <a:schemeClr val="accent5"/>
-  <a:schemeClr val="accent6"/>
-  <cs:variation/>
-  <cs:variation>
-    <a:lumMod val="60000"/>
-  </cs:variation>
-  <cs:variation>
-    <a:lumMod val="80000"/>
-    <a:lumOff val="20000"/>
-  </cs:variation>
-  <cs:variation>
-    <a:lumMod val="80000"/>
-  </cs:variation>
-  <cs:variation>
-    <a:lumMod val="60000"/>
-    <a:lumOff val="40000"/>
-  </cs:variation>
-  <cs:variation>
-    <a:lumMod val="50000"/>
-  </cs:variation>
-  <cs:variation>
-    <a:lumMod val="70000"/>
-    <a:lumOff val="30000"/>
-  </cs:variation>
-  <cs:variation>
-    <a:lumMod val="70000"/>
-  </cs:variation>
-  <cs:variation>
-    <a:lumMod val="50000"/>
-    <a:lumOff val="50000"/>
-  </cs:variation>
-</cs:colorStyle>
-</file>
-
-<file path=ppt/charts/colors3.xml><?xml version="1.0" encoding="utf-8"?>
 <cs:colorStyle xmlns:cs="http://schemas.microsoft.com/office/drawing/2012/chartStyle" xmlns:a="http://schemas.openxmlformats.org/drawingml/2006/main" meth="cycle" id="10">
   <a:schemeClr val="accent1"/>
   <a:schemeClr val="accent2"/>
@@ -3328,509 +3069,6 @@
 </cs:chartStyle>
 </file>
 
-<file path=ppt/charts/style3.xml><?xml version="1.0" encoding="utf-8"?>
-<cs:chartStyle xmlns:cs="http://schemas.microsoft.com/office/drawing/2012/chartStyle" xmlns:a="http://schemas.openxmlformats.org/drawingml/2006/main" id="201">
-  <cs:axisTitle>
-    <cs:lnRef idx="0"/>
-    <cs:fillRef idx="0"/>
-    <cs:effectRef idx="0"/>
-    <cs:fontRef idx="minor">
-      <a:schemeClr val="tx1">
-        <a:lumMod val="65000"/>
-        <a:lumOff val="35000"/>
-      </a:schemeClr>
-    </cs:fontRef>
-    <cs:defRPr sz="1000" kern="1200"/>
-  </cs:axisTitle>
-  <cs:categoryAxis>
-    <cs:lnRef idx="0"/>
-    <cs:fillRef idx="0"/>
-    <cs:effectRef idx="0"/>
-    <cs:fontRef idx="minor">
-      <a:schemeClr val="tx1">
-        <a:lumMod val="65000"/>
-        <a:lumOff val="35000"/>
-      </a:schemeClr>
-    </cs:fontRef>
-    <cs:spPr>
-      <a:ln w="9525" cap="flat" cmpd="sng" algn="ctr">
-        <a:solidFill>
-          <a:schemeClr val="tx1">
-            <a:lumMod val="15000"/>
-            <a:lumOff val="85000"/>
-          </a:schemeClr>
-        </a:solidFill>
-        <a:round/>
-      </a:ln>
-    </cs:spPr>
-    <cs:defRPr sz="900" kern="1200"/>
-  </cs:categoryAxis>
-  <cs:chartArea mods="allowNoFillOverride allowNoLineOverride">
-    <cs:lnRef idx="0"/>
-    <cs:fillRef idx="0"/>
-    <cs:effectRef idx="0"/>
-    <cs:fontRef idx="minor">
-      <a:schemeClr val="tx1"/>
-    </cs:fontRef>
-    <cs:spPr>
-      <a:solidFill>
-        <a:schemeClr val="bg1"/>
-      </a:solidFill>
-      <a:ln w="9525" cap="flat" cmpd="sng" algn="ctr">
-        <a:solidFill>
-          <a:schemeClr val="tx1">
-            <a:lumMod val="15000"/>
-            <a:lumOff val="85000"/>
-          </a:schemeClr>
-        </a:solidFill>
-        <a:round/>
-      </a:ln>
-    </cs:spPr>
-    <cs:defRPr sz="1000" kern="1200"/>
-  </cs:chartArea>
-  <cs:dataLabel>
-    <cs:lnRef idx="0"/>
-    <cs:fillRef idx="0"/>
-    <cs:effectRef idx="0"/>
-    <cs:fontRef idx="minor">
-      <a:schemeClr val="tx1">
-        <a:lumMod val="75000"/>
-        <a:lumOff val="25000"/>
-      </a:schemeClr>
-    </cs:fontRef>
-    <cs:defRPr sz="900" kern="1200"/>
-  </cs:dataLabel>
-  <cs:dataLabelCallout>
-    <cs:lnRef idx="0"/>
-    <cs:fillRef idx="0"/>
-    <cs:effectRef idx="0"/>
-    <cs:fontRef idx="minor">
-      <a:schemeClr val="dk1">
-        <a:lumMod val="65000"/>
-        <a:lumOff val="35000"/>
-      </a:schemeClr>
-    </cs:fontRef>
-    <cs:spPr>
-      <a:solidFill>
-        <a:schemeClr val="lt1"/>
-      </a:solidFill>
-      <a:ln>
-        <a:solidFill>
-          <a:schemeClr val="dk1">
-            <a:lumMod val="25000"/>
-            <a:lumOff val="75000"/>
-          </a:schemeClr>
-        </a:solidFill>
-      </a:ln>
-    </cs:spPr>
-    <cs:defRPr sz="900" kern="1200"/>
-    <cs:bodyPr rot="0" spcFirstLastPara="1" vertOverflow="clip" horzOverflow="clip" vert="horz" wrap="square" lIns="36576" tIns="18288" rIns="36576" bIns="18288" anchor="ctr" anchorCtr="1">
-      <a:spAutoFit/>
-    </cs:bodyPr>
-  </cs:dataLabelCallout>
-  <cs:dataPoint>
-    <cs:lnRef idx="0"/>
-    <cs:fillRef idx="1">
-      <cs:styleClr val="auto"/>
-    </cs:fillRef>
-    <cs:effectRef idx="0"/>
-    <cs:fontRef idx="minor">
-      <a:schemeClr val="tx1"/>
-    </cs:fontRef>
-  </cs:dataPoint>
-  <cs:dataPoint3D>
-    <cs:lnRef idx="0"/>
-    <cs:fillRef idx="1">
-      <cs:styleClr val="auto"/>
-    </cs:fillRef>
-    <cs:effectRef idx="0"/>
-    <cs:fontRef idx="minor">
-      <a:schemeClr val="tx1"/>
-    </cs:fontRef>
-  </cs:dataPoint3D>
-  <cs:dataPointLine>
-    <cs:lnRef idx="0">
-      <cs:styleClr val="auto"/>
-    </cs:lnRef>
-    <cs:fillRef idx="1"/>
-    <cs:effectRef idx="0"/>
-    <cs:fontRef idx="minor">
-      <a:schemeClr val="tx1"/>
-    </cs:fontRef>
-    <cs:spPr>
-      <a:ln w="28575" cap="rnd">
-        <a:solidFill>
-          <a:schemeClr val="phClr"/>
-        </a:solidFill>
-        <a:round/>
-      </a:ln>
-    </cs:spPr>
-  </cs:dataPointLine>
-  <cs:dataPointMarker>
-    <cs:lnRef idx="0">
-      <cs:styleClr val="auto"/>
-    </cs:lnRef>
-    <cs:fillRef idx="1">
-      <cs:styleClr val="auto"/>
-    </cs:fillRef>
-    <cs:effectRef idx="0"/>
-    <cs:fontRef idx="minor">
-      <a:schemeClr val="tx1"/>
-    </cs:fontRef>
-    <cs:spPr>
-      <a:ln w="9525">
-        <a:solidFill>
-          <a:schemeClr val="phClr"/>
-        </a:solidFill>
-      </a:ln>
-    </cs:spPr>
-  </cs:dataPointMarker>
-  <cs:dataPointMarkerLayout symbol="circle" size="5"/>
-  <cs:dataPointWireframe>
-    <cs:lnRef idx="0">
-      <cs:styleClr val="auto"/>
-    </cs:lnRef>
-    <cs:fillRef idx="1"/>
-    <cs:effectRef idx="0"/>
-    <cs:fontRef idx="minor">
-      <a:schemeClr val="tx1"/>
-    </cs:fontRef>
-    <cs:spPr>
-      <a:ln w="9525" cap="rnd">
-        <a:solidFill>
-          <a:schemeClr val="phClr"/>
-        </a:solidFill>
-        <a:round/>
-      </a:ln>
-    </cs:spPr>
-  </cs:dataPointWireframe>
-  <cs:dataTable>
-    <cs:lnRef idx="0"/>
-    <cs:fillRef idx="0"/>
-    <cs:effectRef idx="0"/>
-    <cs:fontRef idx="minor">
-      <a:schemeClr val="tx1">
-        <a:lumMod val="65000"/>
-        <a:lumOff val="35000"/>
-      </a:schemeClr>
-    </cs:fontRef>
-    <cs:spPr>
-      <a:noFill/>
-      <a:ln w="9525" cap="flat" cmpd="sng" algn="ctr">
-        <a:solidFill>
-          <a:schemeClr val="tx1">
-            <a:lumMod val="15000"/>
-            <a:lumOff val="85000"/>
-          </a:schemeClr>
-        </a:solidFill>
-        <a:round/>
-      </a:ln>
-    </cs:spPr>
-    <cs:defRPr sz="900" kern="1200"/>
-  </cs:dataTable>
-  <cs:downBar>
-    <cs:lnRef idx="0"/>
-    <cs:fillRef idx="0"/>
-    <cs:effectRef idx="0"/>
-    <cs:fontRef idx="minor">
-      <a:schemeClr val="dk1"/>
-    </cs:fontRef>
-    <cs:spPr>
-      <a:solidFill>
-        <a:schemeClr val="dk1">
-          <a:lumMod val="65000"/>
-          <a:lumOff val="35000"/>
-        </a:schemeClr>
-      </a:solidFill>
-      <a:ln w="9525">
-        <a:solidFill>
-          <a:schemeClr val="tx1">
-            <a:lumMod val="65000"/>
-            <a:lumOff val="35000"/>
-          </a:schemeClr>
-        </a:solidFill>
-      </a:ln>
-    </cs:spPr>
-  </cs:downBar>
-  <cs:dropLine>
-    <cs:lnRef idx="0"/>
-    <cs:fillRef idx="0"/>
-    <cs:effectRef idx="0"/>
-    <cs:fontRef idx="minor">
-      <a:schemeClr val="tx1"/>
-    </cs:fontRef>
-    <cs:spPr>
-      <a:ln w="9525" cap="flat" cmpd="sng" algn="ctr">
-        <a:solidFill>
-          <a:schemeClr val="tx1">
-            <a:lumMod val="35000"/>
-            <a:lumOff val="65000"/>
-          </a:schemeClr>
-        </a:solidFill>
-        <a:round/>
-      </a:ln>
-    </cs:spPr>
-  </cs:dropLine>
-  <cs:errorBar>
-    <cs:lnRef idx="0"/>
-    <cs:fillRef idx="0"/>
-    <cs:effectRef idx="0"/>
-    <cs:fontRef idx="minor">
-      <a:schemeClr val="tx1"/>
-    </cs:fontRef>
-    <cs:spPr>
-      <a:ln w="9525" cap="flat" cmpd="sng" algn="ctr">
-        <a:solidFill>
-          <a:schemeClr val="tx1">
-            <a:lumMod val="65000"/>
-            <a:lumOff val="35000"/>
-          </a:schemeClr>
-        </a:solidFill>
-        <a:round/>
-      </a:ln>
-    </cs:spPr>
-  </cs:errorBar>
-  <cs:floor>
-    <cs:lnRef idx="0"/>
-    <cs:fillRef idx="0"/>
-    <cs:effectRef idx="0"/>
-    <cs:fontRef idx="minor">
-      <a:schemeClr val="tx1"/>
-    </cs:fontRef>
-    <cs:spPr>
-      <a:noFill/>
-      <a:ln>
-        <a:noFill/>
-      </a:ln>
-    </cs:spPr>
-  </cs:floor>
-  <cs:gridlineMajor>
-    <cs:lnRef idx="0"/>
-    <cs:fillRef idx="0"/>
-    <cs:effectRef idx="0"/>
-    <cs:fontRef idx="minor">
-      <a:schemeClr val="tx1"/>
-    </cs:fontRef>
-    <cs:spPr>
-      <a:ln w="9525" cap="flat" cmpd="sng" algn="ctr">
-        <a:solidFill>
-          <a:schemeClr val="tx1">
-            <a:lumMod val="15000"/>
-            <a:lumOff val="85000"/>
-          </a:schemeClr>
-        </a:solidFill>
-        <a:round/>
-      </a:ln>
-    </cs:spPr>
-  </cs:gridlineMajor>
-  <cs:gridlineMinor>
-    <cs:lnRef idx="0"/>
-    <cs:fillRef idx="0"/>
-    <cs:effectRef idx="0"/>
-    <cs:fontRef idx="minor">
-      <a:schemeClr val="tx1"/>
-    </cs:fontRef>
-    <cs:spPr>
-      <a:ln w="9525" cap="flat" cmpd="sng" algn="ctr">
-        <a:solidFill>
-          <a:schemeClr val="tx1">
-            <a:lumMod val="5000"/>
-            <a:lumOff val="95000"/>
-          </a:schemeClr>
-        </a:solidFill>
-        <a:round/>
-      </a:ln>
-    </cs:spPr>
-  </cs:gridlineMinor>
-  <cs:hiLoLine>
-    <cs:lnRef idx="0"/>
-    <cs:fillRef idx="0"/>
-    <cs:effectRef idx="0"/>
-    <cs:fontRef idx="minor">
-      <a:schemeClr val="tx1"/>
-    </cs:fontRef>
-    <cs:spPr>
-      <a:ln w="9525" cap="flat" cmpd="sng" algn="ctr">
-        <a:solidFill>
-          <a:schemeClr val="tx1">
-            <a:lumMod val="75000"/>
-            <a:lumOff val="25000"/>
-          </a:schemeClr>
-        </a:solidFill>
-        <a:round/>
-      </a:ln>
-    </cs:spPr>
-  </cs:hiLoLine>
-  <cs:leaderLine>
-    <cs:lnRef idx="0"/>
-    <cs:fillRef idx="0"/>
-    <cs:effectRef idx="0"/>
-    <cs:fontRef idx="minor">
-      <a:schemeClr val="tx1"/>
-    </cs:fontRef>
-    <cs:spPr>
-      <a:ln w="9525" cap="flat" cmpd="sng" algn="ctr">
-        <a:solidFill>
-          <a:schemeClr val="tx1">
-            <a:lumMod val="35000"/>
-            <a:lumOff val="65000"/>
-          </a:schemeClr>
-        </a:solidFill>
-        <a:round/>
-      </a:ln>
-    </cs:spPr>
-  </cs:leaderLine>
-  <cs:legend>
-    <cs:lnRef idx="0"/>
-    <cs:fillRef idx="0"/>
-    <cs:effectRef idx="0"/>
-    <cs:fontRef idx="minor">
-      <a:schemeClr val="tx1">
-        <a:lumMod val="65000"/>
-        <a:lumOff val="35000"/>
-      </a:schemeClr>
-    </cs:fontRef>
-    <cs:defRPr sz="900" kern="1200"/>
-  </cs:legend>
-  <cs:plotArea mods="allowNoFillOverride allowNoLineOverride">
-    <cs:lnRef idx="0"/>
-    <cs:fillRef idx="0"/>
-    <cs:effectRef idx="0"/>
-    <cs:fontRef idx="minor">
-      <a:schemeClr val="tx1"/>
-    </cs:fontRef>
-  </cs:plotArea>
-  <cs:plotArea3D mods="allowNoFillOverride allowNoLineOverride">
-    <cs:lnRef idx="0"/>
-    <cs:fillRef idx="0"/>
-    <cs:effectRef idx="0"/>
-    <cs:fontRef idx="minor">
-      <a:schemeClr val="tx1"/>
-    </cs:fontRef>
-  </cs:plotArea3D>
-  <cs:seriesAxis>
-    <cs:lnRef idx="0"/>
-    <cs:fillRef idx="0"/>
-    <cs:effectRef idx="0"/>
-    <cs:fontRef idx="minor">
-      <a:schemeClr val="tx1">
-        <a:lumMod val="65000"/>
-        <a:lumOff val="35000"/>
-      </a:schemeClr>
-    </cs:fontRef>
-    <cs:defRPr sz="900" kern="1200"/>
-  </cs:seriesAxis>
-  <cs:seriesLine>
-    <cs:lnRef idx="0"/>
-    <cs:fillRef idx="0"/>
-    <cs:effectRef idx="0"/>
-    <cs:fontRef idx="minor">
-      <a:schemeClr val="tx1"/>
-    </cs:fontRef>
-    <cs:spPr>
-      <a:ln w="9525" cap="flat" cmpd="sng" algn="ctr">
-        <a:solidFill>
-          <a:schemeClr val="tx1">
-            <a:lumMod val="35000"/>
-            <a:lumOff val="65000"/>
-          </a:schemeClr>
-        </a:solidFill>
-        <a:round/>
-      </a:ln>
-    </cs:spPr>
-  </cs:seriesLine>
-  <cs:title>
-    <cs:lnRef idx="0"/>
-    <cs:fillRef idx="0"/>
-    <cs:effectRef idx="0"/>
-    <cs:fontRef idx="minor">
-      <a:schemeClr val="tx1">
-        <a:lumMod val="65000"/>
-        <a:lumOff val="35000"/>
-      </a:schemeClr>
-    </cs:fontRef>
-    <cs:defRPr sz="1400" b="0" kern="1200" spc="0" baseline="0"/>
-  </cs:title>
-  <cs:trendline>
-    <cs:lnRef idx="0">
-      <cs:styleClr val="auto"/>
-    </cs:lnRef>
-    <cs:fillRef idx="0"/>
-    <cs:effectRef idx="0"/>
-    <cs:fontRef idx="minor">
-      <a:schemeClr val="tx1"/>
-    </cs:fontRef>
-    <cs:spPr>
-      <a:ln w="19050" cap="rnd">
-        <a:solidFill>
-          <a:schemeClr val="phClr"/>
-        </a:solidFill>
-        <a:prstDash val="sysDot"/>
-      </a:ln>
-    </cs:spPr>
-  </cs:trendline>
-  <cs:trendlineLabel>
-    <cs:lnRef idx="0"/>
-    <cs:fillRef idx="0"/>
-    <cs:effectRef idx="0"/>
-    <cs:fontRef idx="minor">
-      <a:schemeClr val="tx1">
-        <a:lumMod val="65000"/>
-        <a:lumOff val="35000"/>
-      </a:schemeClr>
-    </cs:fontRef>
-    <cs:defRPr sz="900" kern="1200"/>
-  </cs:trendlineLabel>
-  <cs:upBar>
-    <cs:lnRef idx="0"/>
-    <cs:fillRef idx="0"/>
-    <cs:effectRef idx="0"/>
-    <cs:fontRef idx="minor">
-      <a:schemeClr val="dk1"/>
-    </cs:fontRef>
-    <cs:spPr>
-      <a:solidFill>
-        <a:schemeClr val="lt1"/>
-      </a:solidFill>
-      <a:ln w="9525">
-        <a:solidFill>
-          <a:schemeClr val="tx1">
-            <a:lumMod val="15000"/>
-            <a:lumOff val="85000"/>
-          </a:schemeClr>
-        </a:solidFill>
-      </a:ln>
-    </cs:spPr>
-  </cs:upBar>
-  <cs:valueAxis>
-    <cs:lnRef idx="0"/>
-    <cs:fillRef idx="0"/>
-    <cs:effectRef idx="0"/>
-    <cs:fontRef idx="minor">
-      <a:schemeClr val="tx1">
-        <a:lumMod val="65000"/>
-        <a:lumOff val="35000"/>
-      </a:schemeClr>
-    </cs:fontRef>
-    <cs:defRPr sz="900" kern="1200"/>
-  </cs:valueAxis>
-  <cs:wall>
-    <cs:lnRef idx="0"/>
-    <cs:fillRef idx="0"/>
-    <cs:effectRef idx="0"/>
-    <cs:fontRef idx="minor">
-      <a:schemeClr val="tx1"/>
-    </cs:fontRef>
-    <cs:spPr>
-      <a:noFill/>
-      <a:ln>
-        <a:noFill/>
-      </a:ln>
-    </cs:spPr>
-  </cs:wall>
-</cs:chartStyle>
-</file>
-
 <file path=ppt/notesMasters/notesMaster1.xml><?xml version="1.0" encoding="utf-8"?>
 <p:notesMaster xmlns:a="http://schemas.openxmlformats.org/drawingml/2006/main" xmlns:r="http://schemas.openxmlformats.org/officeDocument/2006/relationships" xmlns:p="http://schemas.openxmlformats.org/presentationml/2006/main">
   <p:cSld>
@@ -3913,7 +3151,7 @@
           <a:p>
             <a:fld id="{44623A65-BD25-40B6-8815-498297225DF7}" type="datetimeFigureOut">
               <a:rPr lang="pt-BR" smtClean="0"/>
-              <a:t>07/08/2026</a:t>
+              <a:t>22/10/2026</a:t>
             </a:fld>
             <a:endParaRPr lang="pt-BR" dirty="0"/>
           </a:p>
@@ -4327,7 +3565,7 @@
           <a:p>
             <a:fld id="{5B45E566-B383-4B2D-B951-1136FD38326E}" type="datetimeFigureOut">
               <a:rPr lang="pt-BR" smtClean="0"/>
-              <a:t>07/08/2026</a:t>
+              <a:t>22/10/2026</a:t>
             </a:fld>
             <a:endParaRPr lang="pt-BR" dirty="0"/>
           </a:p>
@@ -4525,7 +3763,7 @@
           <a:p>
             <a:fld id="{5B45E566-B383-4B2D-B951-1136FD38326E}" type="datetimeFigureOut">
               <a:rPr lang="pt-BR" smtClean="0"/>
-              <a:t>07/08/2026</a:t>
+              <a:t>22/10/2026</a:t>
             </a:fld>
             <a:endParaRPr lang="pt-BR" dirty="0"/>
           </a:p>
@@ -4733,7 +3971,7 @@
           <a:p>
             <a:fld id="{5B45E566-B383-4B2D-B951-1136FD38326E}" type="datetimeFigureOut">
               <a:rPr lang="pt-BR" smtClean="0"/>
-              <a:t>07/08/2026</a:t>
+              <a:t>22/10/2026</a:t>
             </a:fld>
             <a:endParaRPr lang="pt-BR" dirty="0"/>
           </a:p>
@@ -4931,7 +4169,7 @@
           <a:p>
             <a:fld id="{5B45E566-B383-4B2D-B951-1136FD38326E}" type="datetimeFigureOut">
               <a:rPr lang="pt-BR" smtClean="0"/>
-              <a:t>07/08/2026</a:t>
+              <a:t>22/10/2026</a:t>
             </a:fld>
             <a:endParaRPr lang="pt-BR" dirty="0"/>
           </a:p>
@@ -5206,7 +4444,7 @@
           <a:p>
             <a:fld id="{5B45E566-B383-4B2D-B951-1136FD38326E}" type="datetimeFigureOut">
               <a:rPr lang="pt-BR" smtClean="0"/>
-              <a:t>07/08/2026</a:t>
+              <a:t>22/10/2026</a:t>
             </a:fld>
             <a:endParaRPr lang="pt-BR" dirty="0"/>
           </a:p>
@@ -5471,7 +4709,7 @@
           <a:p>
             <a:fld id="{5B45E566-B383-4B2D-B951-1136FD38326E}" type="datetimeFigureOut">
               <a:rPr lang="pt-BR" smtClean="0"/>
-              <a:t>07/08/2026</a:t>
+              <a:t>22/10/2026</a:t>
             </a:fld>
             <a:endParaRPr lang="pt-BR" dirty="0"/>
           </a:p>
@@ -5883,7 +5121,7 @@
           <a:p>
             <a:fld id="{5B45E566-B383-4B2D-B951-1136FD38326E}" type="datetimeFigureOut">
               <a:rPr lang="pt-BR" smtClean="0"/>
-              <a:t>07/08/2026</a:t>
+              <a:t>22/10/2026</a:t>
             </a:fld>
             <a:endParaRPr lang="pt-BR" dirty="0"/>
           </a:p>
@@ -6024,7 +5262,7 @@
           <a:p>
             <a:fld id="{5B45E566-B383-4B2D-B951-1136FD38326E}" type="datetimeFigureOut">
               <a:rPr lang="pt-BR" smtClean="0"/>
-              <a:t>07/08/2026</a:t>
+              <a:t>22/10/2026</a:t>
             </a:fld>
             <a:endParaRPr lang="pt-BR" dirty="0"/>
           </a:p>
@@ -6137,7 +5375,7 @@
           <a:p>
             <a:fld id="{5B45E566-B383-4B2D-B951-1136FD38326E}" type="datetimeFigureOut">
               <a:rPr lang="pt-BR" smtClean="0"/>
-              <a:t>07/08/2026</a:t>
+              <a:t>22/10/2026</a:t>
             </a:fld>
             <a:endParaRPr lang="pt-BR" dirty="0"/>
           </a:p>
@@ -6448,7 +5686,7 @@
           <a:p>
             <a:fld id="{5B45E566-B383-4B2D-B951-1136FD38326E}" type="datetimeFigureOut">
               <a:rPr lang="pt-BR" smtClean="0"/>
-              <a:t>07/08/2026</a:t>
+              <a:t>22/10/2026</a:t>
             </a:fld>
             <a:endParaRPr lang="pt-BR" dirty="0"/>
           </a:p>
@@ -6736,7 +5974,7 @@
           <a:p>
             <a:fld id="{5B45E566-B383-4B2D-B951-1136FD38326E}" type="datetimeFigureOut">
               <a:rPr lang="pt-BR" smtClean="0"/>
-              <a:t>07/08/2026</a:t>
+              <a:t>22/10/2026</a:t>
             </a:fld>
             <a:endParaRPr lang="pt-BR" dirty="0"/>
           </a:p>
@@ -7001,7 +6239,7 @@
           <a:p>
             <a:fld id="{5B45E566-B383-4B2D-B951-1136FD38326E}" type="datetimeFigureOut">
               <a:rPr lang="pt-BR" smtClean="0"/>
-              <a:t>07/08/2026</a:t>
+              <a:t>22/10/2026</a:t>
             </a:fld>
             <a:endParaRPr lang="pt-BR" dirty="0"/>
           </a:p>
@@ -7784,7 +7022,7 @@
           <p:nvPr>
             <p:extLst>
               <p:ext uri="{D42A27DB-BD31-4B8C-83A1-F6EECF244321}">
-                <p14:modId xmlns:p14="http://schemas.microsoft.com/office/powerpoint/2010/main" val="4123433930"/>
+                <p14:modId xmlns:p14="http://schemas.microsoft.com/office/powerpoint/2010/main" val="1102391684"/>
               </p:ext>
             </p:extLst>
           </p:nvPr>
@@ -8904,7 +8142,7 @@
                     <a:p>
                       <a:pPr algn="ctr" fontAlgn="ctr"/>
                       <a:r>
-                        <a:rPr lang="pt-BR" sz="1800" b="0" i="0" u="none" strike="noStrike">
+                        <a:rPr lang="pt-BR" sz="1800" b="0" i="0" u="none" strike="noStrike" dirty="0">
                           <a:solidFill>
                             <a:srgbClr val="000000"/>
                           </a:solidFill>
@@ -8962,7 +8200,7 @@
                     <a:p>
                       <a:pPr algn="ctr" fontAlgn="ctr"/>
                       <a:r>
-                        <a:rPr lang="pt-BR" sz="1100" b="0" i="0" u="none" strike="noStrike">
+                        <a:rPr lang="pt-BR" sz="1800" b="0" i="0" u="none" strike="noStrike" dirty="0">
                           <a:solidFill>
                             <a:srgbClr val="000000"/>
                           </a:solidFill>
@@ -9360,7 +8598,7 @@
                     <a:p>
                       <a:pPr algn="ctr" fontAlgn="ctr"/>
                       <a:r>
-                        <a:rPr lang="pt-BR" sz="1800" b="0" i="0" u="none" strike="noStrike">
+                        <a:rPr lang="pt-BR" sz="1800" b="0" i="0" u="none" strike="noStrike" dirty="0">
                           <a:solidFill>
                             <a:srgbClr val="000000"/>
                           </a:solidFill>
@@ -9418,7 +8656,7 @@
                     <a:p>
                       <a:pPr algn="ctr" fontAlgn="ctr"/>
                       <a:r>
-                        <a:rPr lang="pt-BR" sz="1100" b="0" i="0" u="none" strike="noStrike">
+                        <a:rPr lang="pt-BR" sz="1800" b="0" i="0" u="none" strike="noStrike">
                           <a:solidFill>
                             <a:srgbClr val="000000"/>
                           </a:solidFill>
@@ -9874,7 +9112,7 @@
                     <a:p>
                       <a:pPr algn="ctr" fontAlgn="ctr"/>
                       <a:r>
-                        <a:rPr lang="pt-BR" sz="1100" b="0" i="0" u="none" strike="noStrike">
+                        <a:rPr lang="pt-BR" sz="1800" b="0" i="0" u="none" strike="noStrike" dirty="0">
                           <a:solidFill>
                             <a:srgbClr val="000000"/>
                           </a:solidFill>
@@ -10330,7 +9568,7 @@
                     <a:p>
                       <a:pPr algn="ctr" fontAlgn="ctr"/>
                       <a:r>
-                        <a:rPr lang="pt-BR" sz="1100" b="1" i="0" u="none" strike="noStrike">
+                        <a:rPr lang="pt-BR" sz="1800" b="1" i="0" u="none" strike="noStrike" dirty="0">
                           <a:solidFill>
                             <a:srgbClr val="000000"/>
                           </a:solidFill>
@@ -25890,8 +25128,8 @@
           <a:chExt cx="0" cy="0"/>
         </a:xfrm>
       </p:grpSpPr>
-      <mc:AlternateContent xmlns:mc="http://schemas.openxmlformats.org/markup-compatibility/2006">
-        <mc:Choice xmlns:a14="http://schemas.microsoft.com/office/drawing/2010/main" Requires="a14">
+      <mc:AlternateContent xmlns:mc="http://schemas.openxmlformats.org/markup-compatibility/2006" xmlns:a14="http://schemas.microsoft.com/office/drawing/2010/main">
+        <mc:Choice Requires="a14">
           <p:sp>
             <p:nvSpPr>
               <p:cNvPr id="6" name="CaixaDeTexto 5">
@@ -26820,7 +26058,7 @@
             </p:txBody>
           </p:sp>
         </mc:Choice>
-        <mc:Fallback>
+        <mc:Fallback xmlns="">
           <p:sp>
             <p:nvSpPr>
               <p:cNvPr id="6" name="CaixaDeTexto 5">
@@ -27731,7 +26969,7 @@
         <p:spPr>
           <a:xfrm>
             <a:off x="847082" y="680546"/>
-            <a:ext cx="10827959" cy="5390386"/>
+            <a:ext cx="10827959" cy="3174395"/>
           </a:xfrm>
           <a:prstGeom prst="rect">
             <a:avLst/>
@@ -27796,45 +27034,13 @@
             </a:pPr>
             <a:r>
               <a:rPr lang="pt-BR" sz="2400" dirty="0"/>
-              <a:t>Magalhães &amp; Lima — Cap. 1: 1.2</a:t>
+              <a:t>Magalhães &amp; Lima — Cap. 1</a:t>
             </a:r>
-          </a:p>
-          <a:p>
-            <a:pPr>
-              <a:lnSpc>
-                <a:spcPct val="150000"/>
-              </a:lnSpc>
-            </a:pPr>
             <a:r>
-              <a:rPr lang="pt-BR" sz="2400" dirty="0"/>
-              <a:t>Exercícios recomendados:</a:t>
+              <a:rPr lang="pt-BR" sz="2400"/>
+              <a:t>: 1.2</a:t>
             </a:r>
-          </a:p>
-          <a:p>
-            <a:pPr marL="457178" indent="-457178">
-              <a:lnSpc>
-                <a:spcPct val="150000"/>
-              </a:lnSpc>
-              <a:buFont typeface="Arial" panose="020B0604020202020204" pitchFamily="34" charset="0"/>
-              <a:buChar char="•"/>
-            </a:pPr>
-            <a:r>
-              <a:rPr lang="pt-BR" sz="2400" dirty="0"/>
-              <a:t>Bussab, Cap. 2: exercícios 1 ao 8 e 9 ao 20 (gráficos); exercícios 15, 16 e 17 (frequências acumuladas)</a:t>
-            </a:r>
-          </a:p>
-          <a:p>
-            <a:pPr marL="457178" indent="-457178">
-              <a:lnSpc>
-                <a:spcPct val="150000"/>
-              </a:lnSpc>
-              <a:buFont typeface="Arial" panose="020B0604020202020204" pitchFamily="34" charset="0"/>
-              <a:buChar char="•"/>
-            </a:pPr>
-            <a:r>
-              <a:rPr lang="pt-BR" sz="2400" dirty="0"/>
-              <a:t>Bussab, Cap. 3: exercícios de 1 a 13 (medidas de posição)</a:t>
-            </a:r>
+            <a:endParaRPr lang="pt-BR" sz="2400" dirty="0"/>
           </a:p>
         </p:txBody>
       </p:sp>
@@ -27877,6 +27083,162 @@
     <p:extLst>
       <p:ext uri="{BB962C8B-B14F-4D97-AF65-F5344CB8AC3E}">
         <p14:creationId xmlns:p14="http://schemas.microsoft.com/office/powerpoint/2010/main" val="2878052133"/>
+      </p:ext>
+    </p:extLst>
+  </p:cSld>
+  <p:clrMapOvr>
+    <a:masterClrMapping/>
+  </p:clrMapOvr>
+</p:sld>
+</file>
+
+<file path=ppt/slides/slide35.xml><?xml version="1.0" encoding="utf-8"?>
+<p:sld xmlns:a="http://schemas.openxmlformats.org/drawingml/2006/main" xmlns:r="http://schemas.openxmlformats.org/officeDocument/2006/relationships" xmlns:p="http://schemas.openxmlformats.org/presentationml/2006/main">
+  <p:cSld>
+    <p:spTree>
+      <p:nvGrpSpPr>
+        <p:cNvPr id="1" name=""/>
+        <p:cNvGrpSpPr/>
+        <p:nvPr/>
+      </p:nvGrpSpPr>
+      <p:grpSpPr>
+        <a:xfrm>
+          <a:off x="0" y="0"/>
+          <a:ext cx="0" cy="0"/>
+          <a:chOff x="0" y="0"/>
+          <a:chExt cx="0" cy="0"/>
+        </a:xfrm>
+      </p:grpSpPr>
+      <p:sp>
+        <p:nvSpPr>
+          <p:cNvPr id="6" name="CaixaDeTexto 5">
+            <a:extLst>
+              <a:ext uri="{FF2B5EF4-FFF2-40B4-BE49-F238E27FC236}">
+                <a16:creationId xmlns:a16="http://schemas.microsoft.com/office/drawing/2014/main" id="{720B10DA-C761-4DEE-8D86-E170E1C2E981}"/>
+              </a:ext>
+            </a:extLst>
+          </p:cNvPr>
+          <p:cNvSpPr txBox="1"/>
+          <p:nvPr/>
+        </p:nvSpPr>
+        <p:spPr>
+          <a:xfrm>
+            <a:off x="847082" y="680546"/>
+            <a:ext cx="10827959" cy="4282391"/>
+          </a:xfrm>
+          <a:prstGeom prst="rect">
+            <a:avLst/>
+          </a:prstGeom>
+          <a:noFill/>
+        </p:spPr>
+        <p:txBody>
+          <a:bodyPr wrap="square" rtlCol="0">
+            <a:spAutoFit/>
+          </a:bodyPr>
+          <a:lstStyle/>
+          <a:p>
+            <a:r>
+              <a:rPr lang="pt-BR" sz="2400" b="1" dirty="0"/>
+              <a:t>Atividades referentes </a:t>
+            </a:r>
+            <a:r>
+              <a:rPr lang="pt-BR" sz="2400" b="1"/>
+              <a:t>à aula (continuação)</a:t>
+            </a:r>
+            <a:endParaRPr lang="pt-BR" sz="2400" b="1" dirty="0"/>
+          </a:p>
+          <a:p>
+            <a:pPr>
+              <a:lnSpc>
+                <a:spcPct val="150000"/>
+              </a:lnSpc>
+            </a:pPr>
+            <a:r>
+              <a:rPr lang="pt-BR" sz="2400"/>
+              <a:t>Exercícios recomendados:</a:t>
+            </a:r>
+          </a:p>
+          <a:p>
+            <a:pPr marL="457200" indent="-457200">
+              <a:lnSpc>
+                <a:spcPct val="150000"/>
+              </a:lnSpc>
+              <a:buFont typeface="Arial" panose="020B0604020202020204" pitchFamily="34" charset="0"/>
+              <a:buChar char="•"/>
+            </a:pPr>
+            <a:r>
+              <a:rPr lang="pt-BR" sz="2400"/>
+              <a:t>Bussab &amp; Morettin — Cap. 2: Problemas 1, 2, 3, 4, 6 e 7; Cap. 3: Problemas 1, 2, 4 e 6</a:t>
+            </a:r>
+          </a:p>
+          <a:p>
+            <a:pPr marL="457200" indent="-457200">
+              <a:lnSpc>
+                <a:spcPct val="150000"/>
+              </a:lnSpc>
+              <a:buFont typeface="Arial" panose="020B0604020202020204" pitchFamily="34" charset="0"/>
+              <a:buChar char="•"/>
+            </a:pPr>
+            <a:r>
+              <a:rPr lang="pt-BR" sz="2400"/>
+              <a:t>Magalhães &amp; Lima — Cap. 1: Exercícios 2, 3, 7, 8, 18 e 20; Cap. 4: Exercícios 3, 4, 5 e 11</a:t>
+            </a:r>
+          </a:p>
+          <a:p>
+            <a:pPr marL="457200" indent="-457200">
+              <a:lnSpc>
+                <a:spcPct val="150000"/>
+              </a:lnSpc>
+              <a:buFont typeface="Arial" panose="020B0604020202020204" pitchFamily="34" charset="0"/>
+              <a:buChar char="•"/>
+            </a:pPr>
+            <a:r>
+              <a:rPr lang="pt-BR" sz="2400"/>
+              <a:t>Montgomery &amp; Runger — Cap. 6: Exercícios 6.1.6, 6.1.7, 6.1.8, 6.1.9, 6.1.11, 6.2.2, 6.2.4, 6.3.2, 6.3.6 e 6.3.9</a:t>
+            </a:r>
+            <a:endParaRPr lang="pt-BR" sz="2400" dirty="0"/>
+          </a:p>
+        </p:txBody>
+      </p:sp>
+      <p:sp>
+        <p:nvSpPr>
+          <p:cNvPr id="7" name="CaixaDeTexto 6">
+            <a:extLst>
+              <a:ext uri="{FF2B5EF4-FFF2-40B4-BE49-F238E27FC236}">
+                <a16:creationId xmlns:a16="http://schemas.microsoft.com/office/drawing/2014/main" id="{A49F6C3D-C6CD-46EB-B00C-3C31995D5B04}"/>
+              </a:ext>
+            </a:extLst>
+          </p:cNvPr>
+          <p:cNvSpPr txBox="1"/>
+          <p:nvPr/>
+        </p:nvSpPr>
+        <p:spPr>
+          <a:xfrm>
+            <a:off x="361395" y="6464300"/>
+            <a:ext cx="4827604" cy="307777"/>
+          </a:xfrm>
+          <a:prstGeom prst="rect">
+            <a:avLst/>
+          </a:prstGeom>
+          <a:noFill/>
+        </p:spPr>
+        <p:txBody>
+          <a:bodyPr wrap="none" rtlCol="0">
+            <a:spAutoFit/>
+          </a:bodyPr>
+          <a:lstStyle/>
+          <a:p>
+            <a:r>
+              <a:rPr lang="pt-BR" sz="1400" dirty="0"/>
+              <a:t>CEA055 - Estatística e Probabilidade - Prof. Marcos Goulart Lima</a:t>
+            </a:r>
+          </a:p>
+        </p:txBody>
+      </p:sp>
+    </p:spTree>
+    <p:extLst>
+      <p:ext uri="{BB962C8B-B14F-4D97-AF65-F5344CB8AC3E}">
+        <p14:creationId xmlns:p14="http://schemas.microsoft.com/office/powerpoint/2010/main" val="286178377"/>
       </p:ext>
     </p:extLst>
   </p:cSld>

</xml_diff>

<commit_message>
CEA055 Aulas 1-15: itens 8-17 da auditoria de 22/10
- Capas das Aulas 1-13 e _aula.yaml: título do Montgomery em português
- Capas das Aulas 1-3: "Objetivos da aula"
- Aula 8, slide 3: cabeçalho da tabela P(X)
- Aula 4: PDF do site renomeado para _SITE.pdf
- Aula 15: lista e gabarito com cabeçalho "15"

Co-Authored-By: Claude Opus 5.5 <noreply@anthropic.com>
</commit_message>
<xml_diff>
--- a/content/2026-2/cea055-estatistica-probabilidade/01-estatistica-descritiva-i/Aula_01_Estatistica_Descritiva_I.pptx
+++ b/content/2026-2/cea055-estatistica-probabilidade/01-estatistica-descritiva-i/Aula_01_Estatistica_Descritiva_I.pptx
@@ -6740,9 +6740,10 @@
               </a:lnSpc>
             </a:pPr>
             <a:r>
-              <a:rPr lang="pt-BR" sz="2400" b="1" dirty="0"/>
-              <a:t>Objetivos do aula:</a:t>
+              <a:rPr lang="pt-BR" sz="2400" b="1"/>
+              <a:t>Objetivos da aula:</a:t>
             </a:r>
+            <a:endParaRPr lang="pt-BR" sz="2400" b="1" dirty="0"/>
           </a:p>
           <a:p>
             <a:pPr marL="285737" indent="-285737">
@@ -6799,15 +6800,23 @@
             </a:pPr>
             <a:r>
               <a:rPr lang="pt-BR" sz="2400" dirty="0"/>
-              <a:t>Montgomery, Runger. </a:t>
+              <a:t>Montgomery, Runger</a:t>
             </a:r>
             <a:r>
-              <a:rPr lang="pt-BR" sz="2400" b="1" dirty="0"/>
-              <a:t>Applied Statistics and Probability for Engineers</a:t>
+              <a:rPr lang="pt-BR" sz="2400"/>
+              <a:t>. </a:t>
+            </a:r>
+            <a:r>
+              <a:rPr lang="pt-BR" sz="2400" b="1"/>
+              <a:t>Estatística Aplicada e Probabilidade para Engenheiros</a:t>
+            </a:r>
+            <a:r>
+              <a:rPr lang="pt-BR" sz="2400"/>
+              <a:t>, 7ª ed. — </a:t>
             </a:r>
             <a:r>
               <a:rPr lang="pt-BR" sz="2400" dirty="0"/>
-              <a:t>, 7th ed — Cap. 6 (6.1 a 6.3)</a:t>
+              <a:t>Cap. 6 (6.1 a 6.3)</a:t>
             </a:r>
           </a:p>
           <a:p>
@@ -24936,7 +24945,127 @@
                       <a:rPr lang="pt-BR" sz="2800" b="0" i="1" smtClean="0">
                         <a:latin typeface="Cambria Math" panose="02040503050406030204" pitchFamily="18" charset="0"/>
                       </a:rPr>
-                      <m:t>{4,0,5,1,7,2,3,3,5,1}</m:t>
+                      <m:t>{</m:t>
+                    </m:r>
+                    <m:r>
+                      <a:rPr lang="pt-BR" sz="2800" b="0" i="1" smtClean="0">
+                        <a:latin typeface="Cambria Math" panose="02040503050406030204" pitchFamily="18" charset="0"/>
+                      </a:rPr>
+                      <m:t>4</m:t>
+                    </m:r>
+                    <m:r>
+                      <a:rPr lang="pt-BR" sz="2800" b="0" i="1" smtClean="0">
+                        <a:latin typeface="Cambria Math" panose="02040503050406030204" pitchFamily="18" charset="0"/>
+                      </a:rPr>
+                      <m:t>,</m:t>
+                    </m:r>
+                    <m:r>
+                      <a:rPr lang="pt-BR" sz="2800" b="0" i="1" smtClean="0">
+                        <a:latin typeface="Cambria Math" panose="02040503050406030204" pitchFamily="18" charset="0"/>
+                      </a:rPr>
+                      <m:t>0</m:t>
+                    </m:r>
+                    <m:r>
+                      <a:rPr lang="pt-BR" sz="2800" b="0" i="1" smtClean="0">
+                        <a:latin typeface="Cambria Math" panose="02040503050406030204" pitchFamily="18" charset="0"/>
+                      </a:rPr>
+                      <m:t>,</m:t>
+                    </m:r>
+                    <m:r>
+                      <a:rPr lang="pt-BR" sz="2800" b="0" i="1" smtClean="0">
+                        <a:latin typeface="Cambria Math" panose="02040503050406030204" pitchFamily="18" charset="0"/>
+                      </a:rPr>
+                      <m:t>5</m:t>
+                    </m:r>
+                    <m:r>
+                      <a:rPr lang="pt-BR" sz="2800" b="0" i="1" smtClean="0">
+                        <a:latin typeface="Cambria Math" panose="02040503050406030204" pitchFamily="18" charset="0"/>
+                      </a:rPr>
+                      <m:t>,</m:t>
+                    </m:r>
+                    <m:r>
+                      <a:rPr lang="pt-BR" sz="2800" b="0" i="1" smtClean="0">
+                        <a:latin typeface="Cambria Math" panose="02040503050406030204" pitchFamily="18" charset="0"/>
+                      </a:rPr>
+                      <m:t>1</m:t>
+                    </m:r>
+                    <m:r>
+                      <a:rPr lang="pt-BR" sz="2800" b="0" i="1" smtClean="0">
+                        <a:latin typeface="Cambria Math" panose="02040503050406030204" pitchFamily="18" charset="0"/>
+                      </a:rPr>
+                      <m:t>,</m:t>
+                    </m:r>
+                    <m:r>
+                      <a:rPr lang="pt-BR" sz="2800" b="0" i="1" smtClean="0">
+                        <a:latin typeface="Cambria Math" panose="02040503050406030204" pitchFamily="18" charset="0"/>
+                      </a:rPr>
+                      <m:t>7</m:t>
+                    </m:r>
+                    <m:r>
+                      <a:rPr lang="pt-BR" sz="2800" b="0" i="1" smtClean="0">
+                        <a:latin typeface="Cambria Math" panose="02040503050406030204" pitchFamily="18" charset="0"/>
+                      </a:rPr>
+                      <m:t>,</m:t>
+                    </m:r>
+                    <m:r>
+                      <a:rPr lang="pt-BR" sz="2800" b="0" i="1" smtClean="0">
+                        <a:latin typeface="Cambria Math" panose="02040503050406030204" pitchFamily="18" charset="0"/>
+                      </a:rPr>
+                      <m:t>2</m:t>
+                    </m:r>
+                    <m:r>
+                      <a:rPr lang="pt-BR" sz="2800" b="0" i="1" smtClean="0">
+                        <a:latin typeface="Cambria Math" panose="02040503050406030204" pitchFamily="18" charset="0"/>
+                      </a:rPr>
+                      <m:t>,</m:t>
+                    </m:r>
+                    <m:r>
+                      <a:rPr lang="pt-BR" sz="2800" b="0" i="1" smtClean="0">
+                        <a:latin typeface="Cambria Math" panose="02040503050406030204" pitchFamily="18" charset="0"/>
+                      </a:rPr>
+                      <m:t>3</m:t>
+                    </m:r>
+                    <m:r>
+                      <a:rPr lang="pt-BR" sz="2800" b="0" i="1" smtClean="0">
+                        <a:latin typeface="Cambria Math" panose="02040503050406030204" pitchFamily="18" charset="0"/>
+                      </a:rPr>
+                      <m:t>,</m:t>
+                    </m:r>
+                    <m:r>
+                      <a:rPr lang="pt-BR" sz="2800" b="0" i="1" smtClean="0">
+                        <a:latin typeface="Cambria Math" panose="02040503050406030204" pitchFamily="18" charset="0"/>
+                      </a:rPr>
+                      <m:t>3</m:t>
+                    </m:r>
+                    <m:r>
+                      <a:rPr lang="pt-BR" sz="2800" b="0" i="1" smtClean="0">
+                        <a:latin typeface="Cambria Math" panose="02040503050406030204" pitchFamily="18" charset="0"/>
+                      </a:rPr>
+                      <m:t>,</m:t>
+                    </m:r>
+                    <m:r>
+                      <a:rPr lang="pt-BR" sz="2800" b="0" i="1" smtClean="0">
+                        <a:latin typeface="Cambria Math" panose="02040503050406030204" pitchFamily="18" charset="0"/>
+                      </a:rPr>
+                      <m:t>5</m:t>
+                    </m:r>
+                    <m:r>
+                      <a:rPr lang="pt-BR" sz="2800" b="0" i="1" smtClean="0">
+                        <a:latin typeface="Cambria Math" panose="02040503050406030204" pitchFamily="18" charset="0"/>
+                      </a:rPr>
+                      <m:t>,</m:t>
+                    </m:r>
+                    <m:r>
+                      <a:rPr lang="pt-BR" sz="2800" b="0" i="1" smtClean="0">
+                        <a:latin typeface="Cambria Math" panose="02040503050406030204" pitchFamily="18" charset="0"/>
+                      </a:rPr>
+                      <m:t>1</m:t>
+                    </m:r>
+                    <m:r>
+                      <a:rPr lang="pt-BR" sz="2800" b="0" i="1" smtClean="0">
+                        <a:latin typeface="Cambria Math" panose="02040503050406030204" pitchFamily="18" charset="0"/>
+                      </a:rPr>
+                      <m:t>}</m:t>
                     </m:r>
                   </m:oMath>
                 </a14:m>
@@ -28420,7 +28549,13 @@
                       <a:rPr lang="pt-BR" sz="2800" b="0" i="1" dirty="0" smtClean="0">
                         <a:latin typeface="Cambria Math" panose="02040503050406030204" pitchFamily="18" charset="0"/>
                       </a:rPr>
-                      <m:t>100∗</m:t>
+                      <m:t>100</m:t>
+                    </m:r>
+                    <m:r>
+                      <a:rPr lang="pt-BR" sz="2800" b="0" i="1" dirty="0" smtClean="0">
+                        <a:latin typeface="Cambria Math" panose="02040503050406030204" pitchFamily="18" charset="0"/>
+                      </a:rPr>
+                      <m:t>∗</m:t>
                     </m:r>
                     <m:sSub>
                       <m:sSubPr>

</xml_diff>